<commit_message>
docs(slides): align numbers, charts and figures with the notebook run
- values, bar charts, highlights and speaker notes match the outputs saved in
  notebooks/fer2013_expressions.ipynb (Colab T4, 2026-10-08)
- figures replaced by the notebook's own plots; AUC values in slide 6 notes updated
- slide 9: E5 has the better disgust F1, E4 kept by the validation-accuracy rule
</commit_message>
<xml_diff>
--- a/soutenance/Soutenance — Reconnaissance d'expressions faciales (2).pptx
+++ b/soutenance/Soutenance — Reconnaissance d'expressions faciales (2).pptx
@@ -598,10 +598,8 @@
           <a:lstStyle/>
           <a:p>
             <a:r>
-              <a:rPr lang="en-US" dirty="0"/>
-              <a:t>Conclusion en trois temps. Ce qui a marché : passer du réseau dense au CNN fait gagner 17 points (34.7% à 51.7%) avec 4,6 fois moins de paramètres, parce que les filtres tiennent compte du voisinage des pixels. En partie 6, c'est l'augmentation qui apporte le plus (52.9% à 60.3%) : elle réduit le surapprentissage, les courbes train et validation montent ensemble. Les autres changements (couches Dense, batch normalization, dropout, baisse du learning rate) font moins d'un point et demi, ce qui peut venir du hasard. Et pour choisir un modèle avec des classes déséquilibrées, on a regardé le rappel, la précision et le F1 par classe en plus de l'accuracy. Le score sur le test (60.7%) est proche de celui de validation (60.3%) : le choix tient. Les limites : fear et disgust restent mal reconnues ; tout vient d'une seule exécution avec une seule seed ; le modèle a appris sur des visages déjà recadrés, sur une photo entière il se trompera ; certaines étiquettes de FER2013 ont l'air fausses, ce qu'on n'a pas mesuré. La suite qu'on propose : refaire l'entraînement avec SGD au lieu d'Adam, ce qu'on n'a pas testé. Tous nos modèles utilisent Adam avec son learning rate par défaut (0.001). Adam adapte le pas de chaque poids, il converge vite et marche sans réglage, c'est pour ça qu'on l'a pris. SGD (descente de gradient stochastique) utilise le même pas pour tous les poids. Il est plus lent et plus sensible au réglage, mais sur les CNN de classification d'images il généralise souvent aussi bien ou mieux qu'Adam quand il est bien réglé. Ce qu'il faudrait régler : un momentum (0.9, qui garde l'élan des mises à jour précédentes), un learning rate plus grand que celui d'Adam (à chercher entre 0.01 et 0.1), une baisse du learning rate pendant l'entraînement (on a déjà ReduceLROnPlateau depuis E0) et plus d'époques, parce que SGD met plus de temps à converger. En Keras : keras.optimizers.SGD(learning_rate=0.01, momentum=0.9). Pour que la comparaison soit honnête : même modèle (E4), même seed, mêmes données, on ne change que l'optimiseur, et on compare sur la validation. Ce qu'on attend : un gain possible mais petit, de l'ordre d'un point. Nos écarts d'une exécution à l'autre sont déjà de cet ordre, donc il faudrait plusieurs seeds pour conclure. Ce n'est pas l'optimiseur qui limite le plus notre modèle, c'est le surapprentissage et la qualité des données. Autres pistes à citer si on nous le demande : entraîner E4 plus longtemps (sa meilleure époque est la dernière), des poids de classe plus doux que ceux de E5, le transfer learning à partir d'un réseau pré-entraîné, et une détection de visages avant le classifieur (parties 7 à 9 du sujet, qu'on n'a pas faites). Puis la démo : on recharge le modèle sauvegardé, on prépare une image comme à l'entraînement (gris, 48x48, divisée par 255) et on affiche les 7 probabilités.</a:t>
-            </a:r>
-            <a:endParaRPr lang="en-US" dirty="0"/>
+              <a:t>Conclusion en trois temps. Ce qui a marché : passer du réseau dense au CNN fait gagner près de 17 points (34.2% à 50.9%) avec 4,6 fois moins de paramètres, parce que les filtres tiennent compte du voisinage des pixels. En partie 6, c'est l'augmentation qui apporte le plus (51.1% à 60.2%, +9 points) : elle réduit le surapprentissage, les courbes train et validation montent ensemble. Les autres changements (couches Dense, batch normalization, dropout, baisse du learning rate) font chacun moins d'un point et demi, ce qui peut venir du hasard ; les deux blocs de convolution en plus ont même fait perdre 2.4 points avant l'augmentation. Et pour choisir un modèle avec des classes déséquilibrées, on a regardé le rappel, la précision et le F1 par classe en plus de l'accuracy. Le score sur le test (61.2%) est proche de celui de validation (60.2%) : le choix tient. Les limites : fear et disgust restent mal reconnues ; tout vient d'une seule exécution avec une seule seed ; le modèle a appris sur des visages déjà recadrés, sur une photo entière il se trompera ; certaines étiquettes de FER2013 ont l'air fausses, ce qu'on n'a pas mesuré. La suite qu'on propose : refaire l'entraînement avec SGD au lieu d'Adam, ce qu'on n'a pas testé. Tous nos modèles utilisent Adam avec son learning rate par défaut (0.001). Adam adapte le pas de chaque poids, il converge vite et marche sans réglage, c'est pour ça qu'on l'a pris. SGD (descente de gradient stochastique) utilise le même pas pour tous les poids. Il est plus lent et plus sensible au réglage, mais sur les CNN de classification d'images il généralise souvent aussi bien ou mieux qu'Adam quand il est bien réglé. Ce qu'il faudrait régler : un momentum (0.9, qui garde l'élan des mises à jour précédentes), un learning rate plus grand que celui d'Adam (à chercher entre 0.01 et 0.1), une baisse du learning rate pendant l'entraînement (on a déjà ReduceLROnPlateau depuis E0) et plus d'époques, parce que SGD met plus de temps à converger. En Keras : keras.optimizers.SGD(learning_rate=0.01, momentum=0.9). Pour que la comparaison soit honnête : même modèle (E4), même seed, mêmes données, on ne change que l'optimiseur, et on compare sur la validation. Ce qu'on attend : un gain possible mais petit, de l'ordre d'un point. Nos écarts d'une exécution à l'autre sont déjà de cet ordre, donc il faudrait plusieurs seeds pour conclure. Ce n'est pas l'optimiseur qui limite le plus notre modèle, c'est le surapprentissage et la qualité des données. Autres pistes à citer si on nous le demande : entraîner E4 plus longtemps (sa meilleure époque est l'avant-dernière, la 19e sur 20), des poids de classe plus doux que ceux de E5, le transfer learning à partir d'un réseau pré-entraîné, et une détection de visages avant le classifieur (parties 7 à 9 du sujet, qu'on n'a pas faites). Puis la démo : on recharge le modèle sauvegardé, on prépare une image comme à l'entraînement (gris, 48x48, divisée par 255) et on affiche les 7 probabilités.</a:t>
+            </a:r>
           </a:p>
         </p:txBody>
       </p:sp>
@@ -774,10 +772,8 @@
           <a:lstStyle/>
           <a:p>
             <a:r>
-              <a:rPr lang="en-US" dirty="0"/>
-              <a:t>C'est le schéma du sujet, il sert de point de comparaison. Chaque neurone fait une somme pondérée des 2304 pixels plus un biais, puis ReLU. Softmax donne 7 probabilités qui font 1 au total, la classe prédite est la plus probable. Paramètres : 2304 x 128 + 128 = 295 040, puis 128 x 7 + 7 = 903. Apprentissage : propagation avant sur un lot de 128 images, calcul de la loss (-log de la proba donnée à la vraie classe), rétropropagation pour avoir le gradient de chaque poids, puis Adam bouge les poids dans le sens qui fait baisser la loss. 34.7% c'est mieux que le hasard (14.3%) et que toujours happy (24.4%), mais faible. Sur l'image d'exemple la baseline trouve la bonne classe, neutral, avec 65%. Un visage un peu décalé devient un vecteur complètement différent, c'est ce que le CNN doit corriger.</a:t>
-            </a:r>
-            <a:endParaRPr lang="en-US" dirty="0"/>
+              <a:t>C'est le schéma du sujet, il sert de point de comparaison. Chaque neurone fait une somme pondérée des 2304 pixels plus un biais, puis ReLU. Softmax donne 7 probabilités qui font 1 au total, la classe prédite est la plus probable. Paramètres : 2304 x 128 + 128 = 295 040, puis 128 x 7 + 7 = 903. Apprentissage : propagation avant sur un lot de 128 images, calcul de la loss (-log de la proba donnée à la vraie classe), rétropropagation pour avoir le gradient de chaque poids, puis Adam bouge les poids dans le sens qui fait baisser la loss. 34.2% c'est mieux que le hasard (14.3%) et que toujours happy (24.4%), mais faible. Sur l'image d'exemple la baseline trouve la bonne classe, neutral, avec 62%. Un visage un peu décalé devient un vecteur complètement différent, c'est ce que le CNN doit corriger.</a:t>
+            </a:r>
           </a:p>
         </p:txBody>
       </p:sp>
@@ -950,10 +946,8 @@
           <a:lstStyle/>
           <a:p>
             <a:r>
-              <a:rPr lang="en-US" dirty="0"/>
-              <a:t>Au début les deux loss baissent ensemble, puis elles se séparent : la loss train continue de baisser alors que la val_loss stagne, atteint son minimum à l'époque 10 (ligne en pointillés, 1.319) puis remonte un peu (1.361 à la fin). L'accuracy train monte jusqu'à 65.3% alors que la validation plafonne vers 52%. C'est du surapprentissage : à partir de la meilleure époque le modèle commence à apprendre les images de train par coeur. L'early stopping s'arrête 6 époques plus tard (époque 16) et remet les poids de la meilleure époque. Écart train/val à la meilleure époque : 6.9 points. Pourquoi ces choix : la cross-entropy devient très grande quand le modèle se trompe en étant sûr de lui ; Adam marche bien sans réglage et la val_loss baisse dès le début ; on ne sait pas à l'avance combien d'époques il faut, c'est la validation qui décide ; patience de 6 plutôt que 3 pour ne pas s'arrêter sur un simple creux ; on surveille val_loss plutôt que val_accuracy parce qu'elle bouge plus finement. On essaie de réduire ce surapprentissage en partie 6 (dropout, augmentation).</a:t>
-            </a:r>
-            <a:endParaRPr lang="en-US" dirty="0"/>
+              <a:t>Au début les deux loss baissent ensemble, puis elles se séparent : la loss train continue de baisser alors que la val_loss stagne, atteint son minimum à l'époque 10 (ligne en pointillés, 1.335) puis remonte (1.372 à la fin). L'accuracy train monte jusqu'à 65.4% alors que la validation plafonne vers 51-52%. C'est du surapprentissage : à partir de la meilleure époque le modèle commence à apprendre les images de train par coeur. L'early stopping s'arrête 6 époques plus tard (époque 16) et remet les poids de la meilleure époque. Écart train/val à la meilleure époque : environ 7.5 points (58.4 contre 50.9). Pourquoi ces choix : la cross-entropy devient très grande quand le modèle se trompe en étant sûr de lui ; Adam marche bien sans réglage et la val_loss baisse dès le début ; on ne sait pas à l'avance combien d'époques il faut, c'est la validation qui décide ; patience de 6 plutôt que 3 pour ne pas s'arrêter sur un simple creux ; on surveille val_loss plutôt que val_accuracy parce qu'elle bouge plus finement. On essaie de réduire ce surapprentissage en partie 6 (dropout, augmentation).</a:t>
+            </a:r>
           </a:p>
         </p:txBody>
       </p:sp>
@@ -1038,10 +1032,8 @@
           <a:lstStyle/>
           <a:p>
             <a:r>
-              <a:rPr lang="en-US" dirty="0"/>
-              <a:t>MATRICE ET RAPPEL. Ligne = vraie classe, colonne = classe prédite, la diagonale = les bonnes réponses. Rappel d'une classe = bonnes réponses / nombre d'images de la classe. happy (75.4%) et surprise (66.8%) sont les mieux reconnues : le sourire, la bouche et les yeux grands ouverts se voient même en 48x48. Les plus dures : fear (22.9%), disgust (25.7%, 18 sur 70), sad (36.5%). Les grosses confusions passent presque toutes par sad et neutral : bouche fermée, la différence se joue sur quelques pixels. disgust : surtout un manque d'images, 16 fois moins que happy. MÉMO ROC. Une courbe par classe, la classe contre toutes les autres. Pour une classe, par exemple happy, on regarde seulement la probabilité happy donnée par le modèle et on fait varier un seuil : au-dessus on dit happy, en dessous on dit pas happy. Chaque seuil donne un point de la courbe. En ordonnée, le taux de vrais positifs : parmi les vraies images happy, la part qu'on retrouve (c'est le rappel). En abscisse, le taux de faux positifs : parmi les images des autres classes, la part qu'on prend à tort pour happy. Un bon modèle retrouve beaucoup de vraies images sans fausses alertes : sa courbe monte vite et colle au coin en haut à gauche. La diagonale en pointillés, c'est un modèle qui répond au hasard. MÉMO AUC. C'est l'aire sous la courbe ROC : 1 = séparation parfaite, 0.5 = hasard. On peut la lire comme une probabilité : si on prend une image de la classe et une image d'une autre classe, c'est la chance que le modèle donne une probabilité plus haute à la bonne. AUC DE CHAQUE CLASSE (légende du graphique). surprise 0.91 et happy 0.90 : les mieux séparées, comme dans la matrice. disgust 0.86 : bonne AUC alors que son rappel est faible (25.7%). Les probabilités disgust sont bien plus hautes sur les vraies images disgust que sur les autres, mais elles dépassent rarement celles des classes fréquentes, donc disgust est rarement la classe prédite. Le modèle sait la repérer, c'est la décision finale qui la pénalise : c'est pour ça que les poids par classe (E5) font monter son rappel. Sa courbe est en escalier parce qu'il n'y a que 70 images. neutral 0.80 et angry 0.79 : moyennes. sad 0.76 et fear 0.73 : les plus basses, ce sont les classes vraiment mélangées avec les autres, même en probabilité. À RETENIR. L'AUC juge les probabilités sur tous les seuils, le rappel juge la décision finale : il faut lire les deux ensemble. Pour une classe rare, le taux de faux positifs reste bas facilement parce qu'il y a beaucoup d'images des autres classes, donc l'AUC peut paraître flatteuse. Autre cause probable des erreurs, non mesurée : des étiquettes fausses dans FER2013.</a:t>
-            </a:r>
-            <a:endParaRPr lang="en-US" dirty="0"/>
+              <a:t>MATRICE ET RAPPEL. Ligne = vraie classe, colonne = classe prédite, la diagonale = les bonnes réponses. Rappel d'une classe = bonnes réponses / nombre d'images de la classe. happy (74.8%) et surprise (63.5%) sont les mieux reconnues : le sourire, la bouche et les yeux grands ouverts se voient même en 48x48. Les plus dures : disgust (18.6%, 13 sur 70), fear (24.8%), sad (38.9%). Les grosses confusions passent presque toutes par sad et neutral : bouche fermée, la différence se joue sur quelques pixels. disgust : surtout un manque d'images, 16 fois moins que happy. MÉMO ROC. Une courbe par classe, la classe contre toutes les autres. Pour une classe, par exemple happy, on regarde seulement la probabilité happy donnée par le modèle et on fait varier un seuil : au-dessus on dit happy, en dessous on dit pas happy. Chaque seuil donne un point de la courbe. En ordonnée, le taux de vrais positifs : parmi les vraies images happy, la part qu'on retrouve (c'est le rappel). En abscisse, le taux de faux positifs : parmi les images des autres classes, la part qu'on prend à tort pour happy. Un bon modèle retrouve beaucoup de vraies images sans fausses alertes : sa courbe monte vite et colle au coin en haut à gauche. La diagonale en pointillés, c'est un modèle qui répond au hasard. MÉMO AUC. C'est l'aire sous la courbe ROC : 1 = séparation parfaite, 0.5 = hasard. On peut la lire comme une probabilité : si on prend une image de la classe et une image d'une autre classe, c'est la chance que le modèle donne une probabilité plus haute à la bonne. AUC DE CHAQUE CLASSE (légende du graphique). surprise 0.90 et happy 0.89 : les mieux séparées, comme dans la matrice. disgust 0.86 : bonne AUC alors que son rappel est faible (18.6%). Les probabilités disgust sont bien plus hautes sur les vraies images disgust que sur les autres, mais elles dépassent rarement celles des classes fréquentes, donc disgust est rarement la classe prédite. Le modèle sait la repérer, c'est la décision finale qui la pénalise : c'est pour ça que les poids par classe (E5) font monter son rappel. Sa courbe est en escalier parce qu'il n'y a que 70 images. neutral 0.79 et angry 0.79 : moyennes. sad 0.76 et fear 0.73 : les plus basses, ce sont les classes vraiment mélangées avec les autres, même en probabilité. À RETENIR. L'AUC juge les probabilités sur tous les seuils, le rappel juge la décision finale : il faut lire les deux ensemble. Pour une classe rare, le taux de faux positifs reste bas facilement parce qu'il y a beaucoup d'images des autres classes, donc l'AUC peut paraître flatteuse. Autre cause probable des erreurs, non mesurée : des étiquettes fausses dans FER2013.</a:t>
+            </a:r>
           </a:p>
         </p:txBody>
       </p:sp>
@@ -1126,10 +1118,8 @@
           <a:lstStyle/>
           <a:p>
             <a:r>
-              <a:rPr lang="en-US" dirty="0"/>
-              <a:t>On regarde les erreurs où le modèle était le plus sûr de lui, ce sont les plus intéressantes. Cinq images étiquetées surprise, angry ou sad sont prédites happy. Pour les deux surprise et une des angry, la personne sourit ou rit : à l'oeil, la prédiction a l'air plus juste que le label. Les deux autres sont des visages d'enfants, plus difficiles à lire. Trois images sont prédites surprise : deux fear avec les yeux écarquillés et les mains sur le visage, et une happy avec la bouche grande ouverte. Le modèle a l'air de se baser surtout sur la bouche et l'ouverture des yeux, moins sur les sourcils. Les images changent un peu d'une exécution à l'autre, mais on retrouve les mêmes types d'erreurs. Les étiquettes douteuses limitent sûrement le score maximum qu'on peut avoir sur FER2013. On ne l'a pas mesuré, c'est une hypothèse à partir des exemples.</a:t>
-            </a:r>
-            <a:endParaRPr lang="en-US" dirty="0"/>
+              <a:t>On regarde les erreurs où le modèle était le plus sûr de lui, ce sont les plus intéressantes. Expressions proches : deux fear sont prédites surprise, yeux écarquillés, bouche ouverte, mains sur le visage ; une happy est prédite surprise, bouche grande ouverte. Étiquettes douteuses : deux images étiquetées surprise sont prédites happy alors que la personne sourit ou rit, à l'oeil la prédiction a l'air plus juste que le label. Images difficiles : une angry prédite happy (grimace qui montre les dents), une sad prédite happy (visage d'enfant), une neutral prédite angry (lunettes, sourcils froncés). Le modèle a l'air de se baser surtout sur la bouche et l'ouverture des yeux, moins sur les sourcils. Les images changent un peu d'une exécution à l'autre, mais on retrouve les mêmes types d'erreurs. Les étiquettes douteuses limitent sûrement le score maximum qu'on peut avoir sur FER2013. On ne l'a pas mesuré, c'est une hypothèse à partir des exemples.</a:t>
+            </a:r>
           </a:p>
         </p:txBody>
       </p:sp>
@@ -1214,10 +1204,8 @@
           <a:lstStyle/>
           <a:p>
             <a:r>
-              <a:rPr lang="en-US" dirty="0"/>
-              <a:t>En haut, le réseau complet : en gris le CNN de base, en couleur ce que chaque expérience ajoute. En bas, l'accuracy de validation de chaque modèle. Chaque expérience part du dernier modèle gardé et change une seule chose. Le reste ne bouge pas : même découpage, seed remise à 42, Adam lr 0.001, batch 128, 20 époques fixes en gardant les poids de la meilleure époque. Seul le CNN de base garde l'early stopping de la partie 4. E0 (learning rate divisé par 2 quand la val_loss ne baisse plus) : 51.1%, pas de gain. E1 (Dense 128 + 64) : 50.5%. E1 bis (batch normalization après chaque convolution) : 50.8%. E2 (dropout 0.3 avant la Dense 128) : 50.8%. E3 (blocs Conv 128 et 256) : 52.9%, loss 1.251. E4 (augmentation : miroir, petite rotation, petit zoom, flou) : le plus gros gain, 60.3%, +7.4 points sur E3, loss 1.075, meilleure époque 20 sur 20 donc le modèle progressait encore. E5 (E4 + poids par classe) : 56.2%, le rappel de disgust monte à 62.9% contre 28.6% pour E4. Du CNN de base à E2 les écarts font moins d'un point et demi : ça peut venir du hasard de l'initialisation. Les vrais effets sont ceux de E3, E4 et E5. Modèle final : E4, choisi par le code avec la règle fixée au début, la meilleure accuracy de validation.</a:t>
-            </a:r>
-            <a:endParaRPr lang="en-US" dirty="0"/>
+              <a:t>En haut, le réseau complet : en gris le CNN de base, en couleur ce que chaque expérience ajoute. En bas, l'accuracy de validation de chaque modèle. Chaque expérience part du dernier modèle gardé et change une seule chose. Le reste ne bouge pas : même découpage, seed remise à 42, Adam lr 0.001, batch 128, 20 époques fixes en gardant les poids de la meilleure époque. Seul le CNN de base garde l'early stopping de la partie 4. E0 (learning rate divisé par 2 quand la val_loss ne baisse plus) : 50.5%, pas de gain. E1 (Dense 128 + 64) : 50.7%. E1 bis (batch normalization après chaque convolution) : 52.1%. E2 (dropout 0.3 avant la Dense 128) : 53.5%, loss 1.281. E3 (blocs Conv 128 et 256) : 51.1%, il perd 2.4 points : il surapprend très vite (meilleure époque 4, accuracy train au-dessus de 90% à la fin). On l'a quand même gardé dans la suite parce que la chaîne était fixée avant le run, on le dit honnêtement. E4 (augmentation : miroir, petite rotation, petit zoom, flou) : le plus gros gain, 60.2%, +9.1 points sur E3 et +6.7 sur E2, loss 1.065, meilleure époque 19 sur 20 donc le modèle progressait encore. L'augmentation corrige justement le surapprentissage du modèle profond. E5 (E4 + poids par classe) : 54.7%, le rappel de disgust monte à 48.6% contre 20.0% pour E4. Les écarts de E0 à E2 font chacun moins d'un point et demi : ça peut venir du hasard de l'initialisation. Le vrai effet est celui de E4. Modèle final : E4, choisi par le code avec la règle fixée au début, la meilleure accuracy de validation.</a:t>
+            </a:r>
           </a:p>
         </p:txBody>
       </p:sp>
@@ -1302,10 +1290,8 @@
           <a:lstStyle/>
           <a:p>
             <a:r>
-              <a:rPr lang="en-US" dirty="0"/>
-              <a:t>Message de la slide : avec des classes déséquilibrées, l'accuracy seule ne suffit pas pour juger un modèle. disgust représente 1.2% de la validation, donc l'accuracy ne voit presque pas si on la reconnaît. On regarde donc aussi les métriques par classe. Rappel = parmi les vraies images disgust, combien on en retrouve. Précision = parmi les images prédites disgust, combien le sont vraiment. F1 = moyenne harmonique des deux. Le rappel seul ne suffit pas non plus : il ne voit pas les fausses alertes. E5 (E4 + poids par classe) retrouve 62.9% des disgust contre 28.6% pour E4, mais sa précision tombe à 20.7% : environ quatre de ses réponses disgust sur cinq sont fausses. Le F1, qui tient compte des deux, est meilleur pour E4 (38.8% contre 31.1%). E4 a aussi la meilleure accuracy (60.3%), la plus petite loss (1.075) et le meilleur F1 sur six classes sur sept. Le modèle final est choisi par le code avec la règle fixée au début, la meilleure accuracy de validation : c'est E4. On ne change pas la règle après avoir vu les résultats. Si le but était de détecter le dégoût à tout prix, quitte à avoir beaucoup de fausses alertes, E5 serait l'alternative. Test, utilisé une seule fois sur le modèle final : 60.7% contre 60.3% en validation, c'est proche, donc le choix fait sur la validation tient sur des images qui n'avaient servi à rien avant. Rappel sur le test : angry 50.8%, disgust 21.6% (24 sur 111), fear 32.8%, happy 86.5%, neutral 70.3%, sad 37.3%, surprise 77.6%.</a:t>
-            </a:r>
-            <a:endParaRPr lang="en-US" dirty="0"/>
+              <a:t>Message de la slide : avec des classes déséquilibrées, l'accuracy seule ne suffit pas pour juger un modèle. disgust représente 1.2% de la validation, donc l'accuracy ne voit presque pas si on la reconnaît. On regarde donc aussi les métriques par classe. Rappel = parmi les vraies images disgust, combien on en retrouve. Précision = parmi les images prédites disgust, combien le sont vraiment. F1 = moyenne harmonique des deux. E5 (E4 + poids par classe) retrouve 48.6% des disgust contre 20.0% pour E4, et son F1 sur disgust est un peu meilleur (35.4% contre 31.5%). Mais sa précision tombe à 27.9% : environ 72% de ses réponses disgust sont fausses, ce sont des images d'autres classes. Et il perd 5.5 points d'accuracy. E4 a la meilleure accuracy (60.2%), la plus petite loss (1.065) et un meilleur F1 que E5 sur les six autres classes. Le modèle final est choisi par le code avec la règle fixée au début, la meilleure accuracy de validation : c'est E4. On ne change pas la règle après avoir vu les résultats. Si le but était de détecter le dégoût à tout prix, quitte à avoir beaucoup de fausses alertes, E5 serait l'alternative. Test, utilisé une seule fois sur le modèle final : 61.2% contre 60.2% en validation, c'est proche, donc le choix fait sur la validation tient sur des images qui n'avaient servi à rien avant. Rappel sur le test : angry 53.7%, disgust 20.7% (23 sur 111), fear 33.2%, happy 80.6%, neutral 74.0%, sad 46.7%, surprise 71.1%.</a:t>
+            </a:r>
           </a:p>
         </p:txBody>
       </p:sp>
@@ -2862,7 +2848,7 @@
                 <a:ea typeface="Space Grotesk" pitchFamily="34" charset="-122"/>
                 <a:cs typeface="Space Grotesk" pitchFamily="34" charset="-120"/>
               </a:rPr>
-              <a:t>De 34.7% à 60.7% : ce qu'on retient</a:t>
+              <a:t>De 34.2% à 61.2% : ce qu'on retient</a:t>
             </a:r>
             <a:endParaRPr lang="en-US" sz="2800" dirty="0"/>
           </a:p>
@@ -2929,7 +2915,7 @@
                 <a:ea typeface="JetBrains Mono" pitchFamily="49" charset="-122"/>
                 <a:cs typeface="JetBrains Mono" pitchFamily="49" charset="-120"/>
               </a:rPr>
-              <a:t>34.7%</a:t>
+              <a:t>34.2%</a:t>
             </a:r>
             <a:endParaRPr lang="en-US" sz="3600" dirty="0"/>
           </a:p>
@@ -3040,7 +3026,7 @@
                 <a:ea typeface="JetBrains Mono" pitchFamily="49" charset="-122"/>
                 <a:cs typeface="JetBrains Mono" pitchFamily="49" charset="-120"/>
               </a:rPr>
-              <a:t>51.7%</a:t>
+              <a:t>50.9%</a:t>
             </a:r>
             <a:endParaRPr lang="en-US" sz="3600" dirty="0"/>
           </a:p>
@@ -3151,7 +3137,7 @@
                 <a:ea typeface="JetBrains Mono" pitchFamily="49" charset="-122"/>
                 <a:cs typeface="JetBrains Mono" pitchFamily="49" charset="-120"/>
               </a:rPr>
-              <a:t>60.3%</a:t>
+              <a:t>60.2%</a:t>
             </a:r>
             <a:endParaRPr lang="en-US" sz="3600" dirty="0"/>
           </a:p>
@@ -3262,7 +3248,7 @@
                 <a:ea typeface="JetBrains Mono" pitchFamily="49" charset="-122"/>
                 <a:cs typeface="JetBrains Mono" pitchFamily="49" charset="-120"/>
               </a:rPr>
-              <a:t>60.7%</a:t>
+              <a:t>61.2%</a:t>
             </a:r>
             <a:endParaRPr lang="en-US" sz="3600" dirty="0"/>
           </a:p>
@@ -4691,7 +4677,7 @@
           <p:nvPr/>
         </p:nvPicPr>
         <p:blipFill>
-          <a:blip r:embed="rId1"/>
+          <a:blip r:embed="rId5"/>
           <a:srcRect l="0" r="0" t="-19" b="-19"/>
           <a:stretch/>
         </p:blipFill>
@@ -4770,7 +4756,7 @@
                 <a:ea typeface="JetBrains Mono" pitchFamily="49" charset="-122"/>
                 <a:cs typeface="JetBrains Mono" pitchFamily="49" charset="-120"/>
               </a:rPr>
-              <a:t>accuracy val baseline: 34.7 %</a:t>
+              <a:t>accuracy val baseline: 34.2 %</a:t>
             </a:r>
             <a:endParaRPr lang="en-US" sz="1200" dirty="0"/>
           </a:p>
@@ -5238,7 +5224,7 @@
                 <a:ea typeface="JetBrains Mono" pitchFamily="49" charset="-122"/>
                 <a:cs typeface="JetBrains Mono" pitchFamily="49" charset="-120"/>
               </a:rPr>
-              <a:t>happy 0.26</a:t>
+              <a:t>happy 0.3</a:t>
             </a:r>
             <a:endParaRPr lang="en-US" sz="1200" dirty="0"/>
           </a:p>
@@ -5282,7 +5268,7 @@
                 <a:ea typeface="JetBrains Mono" pitchFamily="49" charset="-122"/>
                 <a:cs typeface="JetBrains Mono" pitchFamily="49" charset="-120"/>
               </a:rPr>
-              <a:t>neutral 0.65</a:t>
+              <a:t>neutral 0.62</a:t>
             </a:r>
             <a:endParaRPr lang="en-US" sz="1200" dirty="0"/>
           </a:p>
@@ -7703,7 +7689,7 @@
                 <a:ea typeface="Space Grotesk" pitchFamily="34" charset="-122"/>
                 <a:cs typeface="Space Grotesk" pitchFamily="34" charset="-120"/>
               </a:rPr>
-              <a:t>Le CNN atteint 51.7%, puis surapprend après l'époque 10</a:t>
+              <a:t>Le CNN atteint 50.9%, puis surapprend après l'époque 10</a:t>
             </a:r>
             <a:endParaRPr lang="en-US" sz="2800" dirty="0"/>
           </a:p>
@@ -7740,7 +7726,7 @@
           <p:nvPr/>
         </p:nvPicPr>
         <p:blipFill>
-          <a:blip r:embed="rId1"/>
+          <a:blip r:embed="rId4"/>
           <a:srcRect l="0" r="0" t="-51" b="-51"/>
           <a:stretch/>
         </p:blipFill>
@@ -7863,7 +7849,7 @@
                 <a:ea typeface="JetBrains Mono" pitchFamily="49" charset="-122"/>
                 <a:cs typeface="JetBrains Mono" pitchFamily="49" charset="-120"/>
               </a:rPr>
-              <a:t>meilleure époque: acc train 58.6 acc val 51.7 val_loss 1.319</a:t>
+              <a:t>meilleure époque: acc train 58.4 acc val 50.9 val_loss 1.335</a:t>
             </a:r>
             <a:endParaRPr lang="en-US" sz="1200" dirty="0"/>
           </a:p>
@@ -7907,7 +7893,7 @@
                 <a:ea typeface="JetBrains Mono" pitchFamily="49" charset="-122"/>
                 <a:cs typeface="JetBrains Mono" pitchFamily="49" charset="-120"/>
               </a:rPr>
-              <a:t>dernière époque: acc train 65.3 acc val 52.1 val_loss 1.361</a:t>
+              <a:t>dernière époque: acc train 65.4 acc val 52.1 val_loss 1.372</a:t>
             </a:r>
             <a:endParaRPr lang="en-US" sz="1200" dirty="0"/>
           </a:p>
@@ -8391,7 +8377,7 @@
                 <a:ea typeface="DM Sans" pitchFamily="34" charset="-122"/>
                 <a:cs typeface="DM Sans" pitchFamily="34" charset="-120"/>
               </a:rPr>
-              <a:t>Baseline dense : 34.7% en validation. Sorties des cellules 4a et 4b.</a:t>
+              <a:t>Baseline dense : 34.2% en validation. Sorties des cellules 4a et 4b.</a:t>
             </a:r>
             <a:endParaRPr lang="en-US" sz="1200" dirty="0"/>
           </a:p>
@@ -8598,7 +8584,7 @@
           <p:nvPr/>
         </p:nvPicPr>
         <p:blipFill>
-          <a:blip r:embed="rId1"/>
+          <a:blip r:embed="rId5"/>
           <a:srcRect l="-30" r="-30" t="0" b="0"/>
           <a:stretch/>
         </p:blipFill>
@@ -8643,7 +8629,7 @@
           <p:nvPr/>
         </p:nvPicPr>
         <p:blipFill>
-          <a:blip r:embed="rId2"/>
+          <a:blip r:embed="rId6"/>
           <a:srcRect l="-34" r="-34" t="0" b="0"/>
           <a:stretch/>
         </p:blipFill>
@@ -8722,7 +8708,7 @@
                 <a:ea typeface="JetBrains Mono" pitchFamily="49" charset="-122"/>
                 <a:cs typeface="JetBrains Mono" pitchFamily="49" charset="-120"/>
               </a:rPr>
-              <a:t>angry rappel: 45.6 % (354/777)</a:t>
+              <a:t>angry rappel: 43.0 % (334/777)</a:t>
             </a:r>
             <a:endParaRPr lang="en-US" sz="1200" dirty="0"/>
           </a:p>
@@ -8760,13 +8746,13 @@
             <a:r>
               <a:rPr lang="en-US" sz="1200" dirty="0">
                 <a:solidFill>
-                  <a:srgbClr val="D7DCE5"/>
+                  <a:srgbClr val="F5B841"/>
                 </a:solidFill>
                 <a:latin typeface="JetBrains Mono" pitchFamily="49" charset="0"/>
                 <a:ea typeface="JetBrains Mono" pitchFamily="49" charset="-122"/>
                 <a:cs typeface="JetBrains Mono" pitchFamily="49" charset="-120"/>
               </a:rPr>
-              <a:t>disgust rappel: 25.7 % (18/70)</a:t>
+              <a:t>disgust rappel: 18.6 % (13/70)</a:t>
             </a:r>
             <a:endParaRPr lang="en-US" sz="1200" dirty="0"/>
           </a:p>
@@ -8804,13 +8790,13 @@
             <a:r>
               <a:rPr lang="en-US" sz="1200" dirty="0">
                 <a:solidFill>
-                  <a:srgbClr val="F5B841"/>
+                  <a:srgbClr val="D7DCE5"/>
                 </a:solidFill>
                 <a:latin typeface="JetBrains Mono" pitchFamily="49" charset="0"/>
                 <a:ea typeface="JetBrains Mono" pitchFamily="49" charset="-122"/>
                 <a:cs typeface="JetBrains Mono" pitchFamily="49" charset="-120"/>
               </a:rPr>
-              <a:t>fear rappel: 22.9 % (187/816)</a:t>
+              <a:t>fear rappel: 24.8 % (202/816)</a:t>
             </a:r>
             <a:endParaRPr lang="en-US" sz="1200" dirty="0"/>
           </a:p>
@@ -8854,7 +8840,7 @@
                 <a:ea typeface="JetBrains Mono" pitchFamily="49" charset="-122"/>
                 <a:cs typeface="JetBrains Mono" pitchFamily="49" charset="-120"/>
               </a:rPr>
-              <a:t>happy rappel: 75.4 % (1055/1400)</a:t>
+              <a:t>happy rappel: 74.8 % (1047/1400)</a:t>
             </a:r>
             <a:endParaRPr lang="en-US" sz="1200" dirty="0"/>
           </a:p>
@@ -8898,7 +8884,7 @@
                 <a:ea typeface="JetBrains Mono" pitchFamily="49" charset="-122"/>
                 <a:cs typeface="JetBrains Mono" pitchFamily="49" charset="-120"/>
               </a:rPr>
-              <a:t>neutral rappel: 53.2 % (533/1001)</a:t>
+              <a:t>neutral rappel: 50.3 % (504/1001)</a:t>
             </a:r>
             <a:endParaRPr lang="en-US" sz="1200" dirty="0"/>
           </a:p>
@@ -8942,7 +8928,7 @@
                 <a:ea typeface="JetBrains Mono" pitchFamily="49" charset="-122"/>
                 <a:cs typeface="JetBrains Mono" pitchFamily="49" charset="-120"/>
               </a:rPr>
-              <a:t>sad rappel: 36.5 % (362/992)</a:t>
+              <a:t>sad rappel: 38.9 % (386/992)</a:t>
             </a:r>
             <a:endParaRPr lang="en-US" sz="1200" dirty="0"/>
           </a:p>
@@ -8986,7 +8972,7 @@
                 <a:ea typeface="JetBrains Mono" pitchFamily="49" charset="-122"/>
                 <a:cs typeface="JetBrains Mono" pitchFamily="49" charset="-120"/>
               </a:rPr>
-              <a:t>surprise rappel: 66.8 % (456/683)</a:t>
+              <a:t>surprise rappel: 63.5 % (434/683)</a:t>
             </a:r>
             <a:endParaRPr lang="en-US" sz="1200" dirty="0"/>
           </a:p>
@@ -9041,7 +9027,7 @@
                 <a:ea typeface="DM Sans" pitchFamily="34" charset="-122"/>
                 <a:cs typeface="DM Sans" pitchFamily="34" charset="-120"/>
               </a:rPr>
-              <a:t> sad prédit neutral (203), sad prédit angry (153), fear prédit sad (152), neutral prédit sad (150).</a:t>
+              <a:t> sad prise pour neutral (187), neutral pour sad (174), fear pour sad (166), sad pour happy (150).</a:t>
             </a:r>
             <a:endParaRPr lang="en-US" sz="1300" dirty="0"/>
           </a:p>
@@ -9096,7 +9082,7 @@
                 <a:ea typeface="DM Sans" pitchFamily="34" charset="-122"/>
                 <a:cs typeface="DM Sans" pitchFamily="34" charset="-120"/>
               </a:rPr>
-              <a:t> fear n'a pas de signe à elle, disgust manque d'images (436 en train), sad se confond avec neutral.</a:t>
+              <a:t> disgust manque d'images (436 en train), fear n'a pas de signe à elle, sad se confond avec neutral.</a:t>
             </a:r>
             <a:endParaRPr lang="en-US" sz="1300" dirty="0"/>
           </a:p>
@@ -9347,7 +9333,7 @@
           <p:nvPr/>
         </p:nvPicPr>
         <p:blipFill>
-          <a:blip r:embed="rId1"/>
+          <a:blip r:embed="rId4"/>
           <a:srcRect l="-38" r="-38" t="0" b="0"/>
           <a:stretch/>
         </p:blipFill>
@@ -9399,7 +9385,7 @@
                 <a:ea typeface="DM Sans" pitchFamily="34" charset="-122"/>
                 <a:cs typeface="DM Sans" pitchFamily="34" charset="-120"/>
               </a:rPr>
-              <a:t>Sur ces 8 erreurs, le modèle met entre 97% et 99% sur la mauvaise classe et au plus 2% sur la vraie.</a:t>
+              <a:t>Sur ces 8 erreurs, le modèle met entre 97% et 99% sur la mauvaise classe et au plus 3% sur la vraie.</a:t>
             </a:r>
             <a:endParaRPr lang="en-US" sz="1300" dirty="0"/>
           </a:p>
@@ -9575,7 +9561,7 @@
                 <a:ea typeface="DM Sans" pitchFamily="34" charset="-122"/>
                 <a:cs typeface="DM Sans" pitchFamily="34" charset="-120"/>
               </a:rPr>
-              <a:t>surprise et angry prédites happy alors que la personne sourit ou rit.</a:t>
+              <a:t>deux surprise prédites happy alors que la personne sourit ou rit.</a:t>
             </a:r>
             <a:endParaRPr lang="en-US" sz="1300" dirty="0"/>
           </a:p>
@@ -11261,7 +11247,7 @@
         </p:nvSpPr>
         <p:spPr>
           <a:xfrm>
-            <a:off x="1055370" y="3726061"/>
+            <a:off x="1055370" y="3738111"/>
             <a:ext cx="594360" cy="256530"/>
           </a:xfrm>
           <a:prstGeom prst="rect">
@@ -11291,7 +11277,7 @@
                 <a:ea typeface="JetBrains Mono" pitchFamily="49" charset="-122"/>
                 <a:cs typeface="JetBrains Mono" pitchFamily="49" charset="-120"/>
               </a:rPr>
-              <a:t>34.7%</a:t>
+              <a:t>34.2%</a:t>
             </a:r>
             <a:endParaRPr lang="en-US" sz="1300" dirty="0"/>
           </a:p>
@@ -11305,8 +11291,8 @@
         </p:nvSpPr>
         <p:spPr>
           <a:xfrm>
-            <a:off x="1047750" y="3995291"/>
-            <a:ext cx="609600" cy="730250"/>
+            <a:off x="1047750" y="4007341"/>
+            <a:ext cx="609600" cy="718200"/>
           </a:xfrm>
           <a:prstGeom prst="roundRect">
             <a:avLst>
@@ -11415,7 +11401,7 @@
         </p:nvSpPr>
         <p:spPr>
           <a:xfrm>
-            <a:off x="2241233" y="3370461"/>
+            <a:off x="2241233" y="3387411"/>
             <a:ext cx="594360" cy="256530"/>
           </a:xfrm>
           <a:prstGeom prst="rect">
@@ -11445,7 +11431,7 @@
                 <a:ea typeface="JetBrains Mono" pitchFamily="49" charset="-122"/>
                 <a:cs typeface="JetBrains Mono" pitchFamily="49" charset="-120"/>
               </a:rPr>
-              <a:t>51.7%</a:t>
+              <a:t>50.9%</a:t>
             </a:r>
             <a:endParaRPr lang="en-US" sz="1300" dirty="0"/>
           </a:p>
@@ -11459,8 +11445,8 @@
         </p:nvSpPr>
         <p:spPr>
           <a:xfrm>
-            <a:off x="2233613" y="3639691"/>
-            <a:ext cx="609600" cy="1085850"/>
+            <a:off x="2233613" y="3656641"/>
+            <a:ext cx="609600" cy="1068900"/>
           </a:xfrm>
           <a:prstGeom prst="roundRect">
             <a:avLst>
@@ -11569,7 +11555,7 @@
         </p:nvSpPr>
         <p:spPr>
           <a:xfrm>
-            <a:off x="3427095" y="3383161"/>
+            <a:off x="3427095" y="3395811"/>
             <a:ext cx="594360" cy="256530"/>
           </a:xfrm>
           <a:prstGeom prst="rect">
@@ -11599,7 +11585,7 @@
                 <a:ea typeface="JetBrains Mono" pitchFamily="49" charset="-122"/>
                 <a:cs typeface="JetBrains Mono" pitchFamily="49" charset="-120"/>
               </a:rPr>
-              <a:t>51.1%</a:t>
+              <a:t>50.5%</a:t>
             </a:r>
             <a:endParaRPr lang="en-US" sz="1300" dirty="0"/>
           </a:p>
@@ -11613,8 +11599,8 @@
         </p:nvSpPr>
         <p:spPr>
           <a:xfrm>
-            <a:off x="3419475" y="3652391"/>
-            <a:ext cx="609600" cy="1073150"/>
+            <a:off x="3419475" y="3665041"/>
+            <a:ext cx="609600" cy="1060500"/>
           </a:xfrm>
           <a:prstGeom prst="roundRect">
             <a:avLst>
@@ -11723,7 +11709,7 @@
         </p:nvSpPr>
         <p:spPr>
           <a:xfrm>
-            <a:off x="4612958" y="3395861"/>
+            <a:off x="4612958" y="3391611"/>
             <a:ext cx="594360" cy="256530"/>
           </a:xfrm>
           <a:prstGeom prst="rect">
@@ -11753,7 +11739,7 @@
                 <a:ea typeface="JetBrains Mono" pitchFamily="49" charset="-122"/>
                 <a:cs typeface="JetBrains Mono" pitchFamily="49" charset="-120"/>
               </a:rPr>
-              <a:t>50.5%</a:t>
+              <a:t>50.7%</a:t>
             </a:r>
             <a:endParaRPr lang="en-US" sz="1300" dirty="0"/>
           </a:p>
@@ -11767,8 +11753,8 @@
         </p:nvSpPr>
         <p:spPr>
           <a:xfrm>
-            <a:off x="4605338" y="3665091"/>
-            <a:ext cx="609600" cy="1060450"/>
+            <a:off x="4605338" y="3660841"/>
+            <a:ext cx="609600" cy="1064700"/>
           </a:xfrm>
           <a:prstGeom prst="roundRect">
             <a:avLst>
@@ -11877,7 +11863,7 @@
         </p:nvSpPr>
         <p:spPr>
           <a:xfrm>
-            <a:off x="5798820" y="3389511"/>
+            <a:off x="5798820" y="3362211"/>
             <a:ext cx="594360" cy="256530"/>
           </a:xfrm>
           <a:prstGeom prst="rect">
@@ -11907,7 +11893,7 @@
                 <a:ea typeface="JetBrains Mono" pitchFamily="49" charset="-122"/>
                 <a:cs typeface="JetBrains Mono" pitchFamily="49" charset="-120"/>
               </a:rPr>
-              <a:t>50.8%</a:t>
+              <a:t>52.1%</a:t>
             </a:r>
             <a:endParaRPr lang="en-US" sz="1300" dirty="0"/>
           </a:p>
@@ -11921,8 +11907,8 @@
         </p:nvSpPr>
         <p:spPr>
           <a:xfrm>
-            <a:off x="5791200" y="3658741"/>
-            <a:ext cx="609600" cy="1066800"/>
+            <a:off x="5791200" y="3631441"/>
+            <a:ext cx="609600" cy="1094100"/>
           </a:xfrm>
           <a:prstGeom prst="roundRect">
             <a:avLst>
@@ -12031,7 +12017,7 @@
         </p:nvSpPr>
         <p:spPr>
           <a:xfrm>
-            <a:off x="6984683" y="3389511"/>
+            <a:off x="6984683" y="3332811"/>
             <a:ext cx="594360" cy="256530"/>
           </a:xfrm>
           <a:prstGeom prst="rect">
@@ -12061,7 +12047,7 @@
                 <a:ea typeface="JetBrains Mono" pitchFamily="49" charset="-122"/>
                 <a:cs typeface="JetBrains Mono" pitchFamily="49" charset="-120"/>
               </a:rPr>
-              <a:t>50.8%</a:t>
+              <a:t>53.5%</a:t>
             </a:r>
             <a:endParaRPr lang="en-US" sz="1300" dirty="0"/>
           </a:p>
@@ -12075,8 +12061,8 @@
         </p:nvSpPr>
         <p:spPr>
           <a:xfrm>
-            <a:off x="6977063" y="3658741"/>
-            <a:ext cx="609600" cy="1066800"/>
+            <a:off x="6977063" y="3602041"/>
+            <a:ext cx="609600" cy="1123500"/>
           </a:xfrm>
           <a:prstGeom prst="roundRect">
             <a:avLst>
@@ -12185,7 +12171,7 @@
         </p:nvSpPr>
         <p:spPr>
           <a:xfrm>
-            <a:off x="8170545" y="3345061"/>
+            <a:off x="8170545" y="3383211"/>
             <a:ext cx="594360" cy="256530"/>
           </a:xfrm>
           <a:prstGeom prst="rect">
@@ -12215,7 +12201,7 @@
                 <a:ea typeface="JetBrains Mono" pitchFamily="49" charset="-122"/>
                 <a:cs typeface="JetBrains Mono" pitchFamily="49" charset="-120"/>
               </a:rPr>
-              <a:t>52.9%</a:t>
+              <a:t>51.1%</a:t>
             </a:r>
             <a:endParaRPr lang="en-US" sz="1300" dirty="0"/>
           </a:p>
@@ -12229,8 +12215,8 @@
         </p:nvSpPr>
         <p:spPr>
           <a:xfrm>
-            <a:off x="8162925" y="3614291"/>
-            <a:ext cx="609600" cy="1111250"/>
+            <a:off x="8162925" y="3652441"/>
+            <a:ext cx="609600" cy="1073100"/>
           </a:xfrm>
           <a:prstGeom prst="roundRect">
             <a:avLst>
@@ -12339,7 +12325,7 @@
         </p:nvSpPr>
         <p:spPr>
           <a:xfrm>
-            <a:off x="9356408" y="3192661"/>
+            <a:off x="9356408" y="3192111"/>
             <a:ext cx="594360" cy="256530"/>
           </a:xfrm>
           <a:prstGeom prst="rect">
@@ -12369,7 +12355,7 @@
                 <a:ea typeface="JetBrains Mono" pitchFamily="49" charset="-122"/>
                 <a:cs typeface="JetBrains Mono" pitchFamily="49" charset="-120"/>
               </a:rPr>
-              <a:t>60.3%</a:t>
+              <a:t>60.2%</a:t>
             </a:r>
             <a:endParaRPr lang="en-US" sz="1300" dirty="0"/>
           </a:p>
@@ -12383,8 +12369,8 @@
         </p:nvSpPr>
         <p:spPr>
           <a:xfrm>
-            <a:off x="9348788" y="3461891"/>
-            <a:ext cx="609600" cy="1263650"/>
+            <a:off x="9348788" y="3461341"/>
+            <a:ext cx="609600" cy="1264200"/>
           </a:xfrm>
           <a:prstGeom prst="roundRect">
             <a:avLst>
@@ -12493,7 +12479,7 @@
         </p:nvSpPr>
         <p:spPr>
           <a:xfrm>
-            <a:off x="10542270" y="3281561"/>
+            <a:off x="10542270" y="3307611"/>
             <a:ext cx="594360" cy="256530"/>
           </a:xfrm>
           <a:prstGeom prst="rect">
@@ -12523,7 +12509,7 @@
                 <a:ea typeface="JetBrains Mono" pitchFamily="49" charset="-122"/>
                 <a:cs typeface="JetBrains Mono" pitchFamily="49" charset="-120"/>
               </a:rPr>
-              <a:t>56.2%</a:t>
+              <a:t>54.7%</a:t>
             </a:r>
             <a:endParaRPr lang="en-US" sz="1300" dirty="0"/>
           </a:p>
@@ -12537,8 +12523,8 @@
         </p:nvSpPr>
         <p:spPr>
           <a:xfrm>
-            <a:off x="10534650" y="3550791"/>
-            <a:ext cx="609600" cy="1174750"/>
+            <a:off x="10534650" y="3576841"/>
+            <a:ext cx="609600" cy="1148700"/>
           </a:xfrm>
           <a:prstGeom prst="roundRect">
             <a:avLst>
@@ -12677,7 +12663,7 @@
                 <a:ea typeface="DM Sans" pitchFamily="34" charset="-122"/>
                 <a:cs typeface="DM Sans" pitchFamily="34" charset="-120"/>
               </a:rPr>
-              <a:t>Accuracy de validation, 5 739 images. E4 : modèle retenu, meilleure accuracy et plus petite loss (1.075).</a:t>
+              <a:t>Accuracy de validation, 5 739 images. E4 : modèle retenu, meilleure accuracy et plus petite loss (1.065).</a:t>
             </a:r>
             <a:endParaRPr lang="en-US" sz="1200" dirty="0"/>
           </a:p>
@@ -13005,7 +12991,7 @@
         <p:spPr>
           <a:xfrm>
             <a:off x="2921000" y="2655441"/>
-            <a:ext cx="3060700" cy="190500"/>
+            <a:ext cx="3058160" cy="190500"/>
           </a:xfrm>
           <a:prstGeom prst="roundRect">
             <a:avLst>
@@ -13026,7 +13012,7 @@
         </p:nvSpPr>
         <p:spPr>
           <a:xfrm>
-            <a:off x="6057900" y="2644031"/>
+            <a:off x="6055360" y="2644031"/>
             <a:ext cx="548640" cy="238720"/>
           </a:xfrm>
           <a:prstGeom prst="rect">
@@ -13056,7 +13042,7 @@
                 <a:ea typeface="JetBrains Mono" pitchFamily="49" charset="-122"/>
                 <a:cs typeface="JetBrains Mono" pitchFamily="49" charset="-120"/>
               </a:rPr>
-              <a:t>60.3%</a:t>
+              <a:t>60.2%</a:t>
             </a:r>
             <a:endParaRPr lang="en-US" sz="1200" dirty="0"/>
           </a:p>
@@ -13115,7 +13101,7 @@
         <p:spPr>
           <a:xfrm>
             <a:off x="2921000" y="2906861"/>
-            <a:ext cx="2857500" cy="190500"/>
+            <a:ext cx="2778760" cy="190500"/>
           </a:xfrm>
           <a:prstGeom prst="roundRect">
             <a:avLst>
@@ -13136,7 +13122,7 @@
         </p:nvSpPr>
         <p:spPr>
           <a:xfrm>
-            <a:off x="5854700" y="2895451"/>
+            <a:off x="5775960" y="2895451"/>
             <a:ext cx="548640" cy="238720"/>
           </a:xfrm>
           <a:prstGeom prst="rect">
@@ -13166,7 +13152,7 @@
                 <a:ea typeface="JetBrains Mono" pitchFamily="49" charset="-122"/>
                 <a:cs typeface="JetBrains Mono" pitchFamily="49" charset="-120"/>
               </a:rPr>
-              <a:t>56.2%</a:t>
+              <a:t>54.7%</a:t>
             </a:r>
             <a:endParaRPr lang="en-US" sz="1200" dirty="0"/>
           </a:p>
@@ -13269,7 +13255,7 @@
         <p:spPr>
           <a:xfrm>
             <a:off x="2921000" y="3247182"/>
-            <a:ext cx="1454150" cy="190500"/>
+            <a:ext cx="1016000" cy="190500"/>
           </a:xfrm>
           <a:prstGeom prst="roundRect">
             <a:avLst>
@@ -13290,7 +13276,7 @@
         </p:nvSpPr>
         <p:spPr>
           <a:xfrm>
-            <a:off x="4451350" y="3235771"/>
+            <a:off x="4013200" y="3235771"/>
             <a:ext cx="548640" cy="238720"/>
           </a:xfrm>
           <a:prstGeom prst="rect">
@@ -13320,7 +13306,7 @@
                 <a:ea typeface="JetBrains Mono" pitchFamily="49" charset="-122"/>
                 <a:cs typeface="JetBrains Mono" pitchFamily="49" charset="-120"/>
               </a:rPr>
-              <a:t>28.6%</a:t>
+              <a:t>20.0%</a:t>
             </a:r>
             <a:endParaRPr lang="en-US" sz="1200" dirty="0"/>
           </a:p>
@@ -13379,7 +13365,7 @@
         <p:spPr>
           <a:xfrm>
             <a:off x="2921000" y="3498602"/>
-            <a:ext cx="3194050" cy="190500"/>
+            <a:ext cx="2468880" cy="190500"/>
           </a:xfrm>
           <a:prstGeom prst="roundRect">
             <a:avLst>
@@ -13400,7 +13386,7 @@
         </p:nvSpPr>
         <p:spPr>
           <a:xfrm>
-            <a:off x="6191250" y="3487192"/>
+            <a:off x="5466080" y="3487192"/>
             <a:ext cx="548640" cy="238720"/>
           </a:xfrm>
           <a:prstGeom prst="rect">
@@ -13430,7 +13416,7 @@
                 <a:ea typeface="JetBrains Mono" pitchFamily="49" charset="-122"/>
                 <a:cs typeface="JetBrains Mono" pitchFamily="49" charset="-120"/>
               </a:rPr>
-              <a:t>62.9%</a:t>
+              <a:t>48.6%</a:t>
             </a:r>
             <a:endParaRPr lang="en-US" sz="1200" dirty="0"/>
           </a:p>
@@ -13533,7 +13519,7 @@
         <p:spPr>
           <a:xfrm>
             <a:off x="2921000" y="3838922"/>
-            <a:ext cx="3079750" cy="190500"/>
+            <a:ext cx="3743960" cy="190500"/>
           </a:xfrm>
           <a:prstGeom prst="roundRect">
             <a:avLst>
@@ -13554,7 +13540,7 @@
         </p:nvSpPr>
         <p:spPr>
           <a:xfrm>
-            <a:off x="6076950" y="3827512"/>
+            <a:off x="6741160" y="3827512"/>
             <a:ext cx="548640" cy="238720"/>
           </a:xfrm>
           <a:prstGeom prst="rect">
@@ -13584,7 +13570,7 @@
                 <a:ea typeface="JetBrains Mono" pitchFamily="49" charset="-122"/>
                 <a:cs typeface="JetBrains Mono" pitchFamily="49" charset="-120"/>
               </a:rPr>
-              <a:t>60.6%</a:t>
+              <a:t>73.7%</a:t>
             </a:r>
             <a:endParaRPr lang="en-US" sz="1200" dirty="0"/>
           </a:p>
@@ -13643,7 +13629,7 @@
         <p:spPr>
           <a:xfrm>
             <a:off x="2921000" y="4090343"/>
-            <a:ext cx="1054100" cy="190500"/>
+            <a:ext cx="1417320" cy="190500"/>
           </a:xfrm>
           <a:prstGeom prst="roundRect">
             <a:avLst>
@@ -13664,7 +13650,7 @@
         </p:nvSpPr>
         <p:spPr>
           <a:xfrm>
-            <a:off x="4051300" y="4078932"/>
+            <a:off x="4414520" y="4078932"/>
             <a:ext cx="548640" cy="238720"/>
           </a:xfrm>
           <a:prstGeom prst="rect">
@@ -13694,7 +13680,7 @@
                 <a:ea typeface="JetBrains Mono" pitchFamily="49" charset="-122"/>
                 <a:cs typeface="JetBrains Mono" pitchFamily="49" charset="-120"/>
               </a:rPr>
-              <a:t>20.7%</a:t>
+              <a:t>27.9%</a:t>
             </a:r>
             <a:endParaRPr lang="en-US" sz="1200" dirty="0"/>
           </a:p>
@@ -13797,7 +13783,7 @@
         <p:spPr>
           <a:xfrm>
             <a:off x="2921000" y="4430663"/>
-            <a:ext cx="1968500" cy="190500"/>
+            <a:ext cx="1600200" cy="190500"/>
           </a:xfrm>
           <a:prstGeom prst="roundRect">
             <a:avLst>
@@ -13818,7 +13804,7 @@
         </p:nvSpPr>
         <p:spPr>
           <a:xfrm>
-            <a:off x="4965700" y="4419253"/>
+            <a:off x="4597400" y="4419253"/>
             <a:ext cx="548640" cy="238720"/>
           </a:xfrm>
           <a:prstGeom prst="rect">
@@ -13840,15 +13826,15 @@
               <a:buNone/>
             </a:pPr>
             <a:r>
-              <a:rPr lang="en-US" sz="1200" b="1" dirty="0">
-                <a:solidFill>
-                  <a:srgbClr val="F5B841"/>
+              <a:rPr lang="en-US" sz="1200" dirty="0">
+                <a:solidFill>
+                  <a:srgbClr val="A3ABBA"/>
                 </a:solidFill>
                 <a:latin typeface="JetBrains Mono" pitchFamily="49" charset="0"/>
                 <a:ea typeface="JetBrains Mono" pitchFamily="49" charset="-122"/>
                 <a:cs typeface="JetBrains Mono" pitchFamily="49" charset="-120"/>
               </a:rPr>
-              <a:t>38.8%</a:t>
+              <a:t>31.5%</a:t>
             </a:r>
             <a:endParaRPr lang="en-US" sz="1200" dirty="0"/>
           </a:p>
@@ -13907,7 +13893,7 @@
         <p:spPr>
           <a:xfrm>
             <a:off x="2921000" y="4682083"/>
-            <a:ext cx="1581150" cy="190500"/>
+            <a:ext cx="1798320" cy="190500"/>
           </a:xfrm>
           <a:prstGeom prst="roundRect">
             <a:avLst>
@@ -13928,7 +13914,7 @@
         </p:nvSpPr>
         <p:spPr>
           <a:xfrm>
-            <a:off x="4578350" y="4670673"/>
+            <a:off x="4795520" y="4670673"/>
             <a:ext cx="548640" cy="238720"/>
           </a:xfrm>
           <a:prstGeom prst="rect">
@@ -13950,15 +13936,15 @@
               <a:buNone/>
             </a:pPr>
             <a:r>
-              <a:rPr lang="en-US" sz="1200" dirty="0">
-                <a:solidFill>
-                  <a:srgbClr val="A3ABBA"/>
+              <a:rPr lang="en-US" sz="1200" dirty="0" b="1">
+                <a:solidFill>
+                  <a:srgbClr val="F5B841"/>
                 </a:solidFill>
                 <a:latin typeface="JetBrains Mono" pitchFamily="49" charset="0"/>
                 <a:ea typeface="JetBrains Mono" pitchFamily="49" charset="-122"/>
                 <a:cs typeface="JetBrains Mono" pitchFamily="49" charset="-120"/>
               </a:rPr>
-              <a:t>31.1%</a:t>
+              <a:t>35.4%</a:t>
             </a:r>
             <a:endParaRPr lang="en-US" sz="1200" dirty="0"/>
           </a:p>
@@ -14002,7 +13988,7 @@
                 <a:ea typeface="DM Sans" pitchFamily="34" charset="-122"/>
                 <a:cs typeface="DM Sans" pitchFamily="34" charset="-120"/>
               </a:rPr>
-              <a:t>E5 retrouve plus de disgust, mais quatre de ses réponses disgust sur cinq sont fausses. On retient E4.</a:t>
+              <a:t>E5 retrouve plus de disgust, mais 72% de ses réponses disgust sont fausses et il perd 5,5 points. On retient E4.</a:t>
             </a:r>
             <a:endParaRPr lang="en-US" sz="1300" dirty="0"/>
           </a:p>
@@ -14039,7 +14025,7 @@
           <p:nvPr/>
         </p:nvPicPr>
         <p:blipFill>
-          <a:blip r:embed="rId1"/>
+          <a:blip r:embed="rId4"/>
           <a:srcRect l="-48" r="-48" t="0" b="0"/>
           <a:stretch/>
         </p:blipFill>
@@ -14118,7 +14104,7 @@
                 <a:ea typeface="JetBrains Mono" pitchFamily="49" charset="-122"/>
                 <a:cs typeface="JetBrains Mono" pitchFamily="49" charset="-120"/>
               </a:rPr>
-              <a:t>accuracy test: 60.7 %</a:t>
+              <a:t>accuracy test: 61.2 %</a:t>
             </a:r>
             <a:endParaRPr lang="en-US" sz="1200" dirty="0"/>
           </a:p>
@@ -14162,7 +14148,7 @@
                 <a:ea typeface="JetBrains Mono" pitchFamily="49" charset="-122"/>
                 <a:cs typeface="JetBrains Mono" pitchFamily="49" charset="-120"/>
               </a:rPr>
-              <a:t>accuracy val du même modèle: 60.3 %</a:t>
+              <a:t>accuracy val du même modèle: 60.2 %</a:t>
             </a:r>
             <a:endParaRPr lang="en-US" sz="1200" dirty="0"/>
           </a:p>

</xml_diff>